<commit_message>
Improve PPTX generation by fixing layout issues and handling edge cases
Refactor the PPTX generation engine to correctly handle the TWOCOL and BULLETS layouts, and update the TOC slide numbering mechanism.

Replit-Commit-Author: Agent
Replit-Commit-Session-Id: 31942f09-e9fe-48e0-b3a2-e7a43bce705a
Replit-Commit-Checkpoint-Type: full_checkpoint
Replit-Commit-Event-Id: f9ac9e04-bf36-418a-a23c-b7da046ad5ec
Replit-Commit-Screenshot-Url: https://storage.googleapis.com/screenshot-production-us-central1/b27c5302-07cf-4783-8472-27a32e1f225d/31942f09-e9fe-48e0-b3a2-e7a43bce705a/ydnjApZ
Replit-Helium-Checkpoint-Created: true
</commit_message>
<xml_diff>
--- a/template.pptx
+++ b/template.pptx
@@ -7120,7 +7120,7 @@
                 </a:solidFill>
                 <a:latin typeface="Calibri"/>
               </a:rPr>
-              <a:t>01</a:t>
+              <a:t>{{NUM_1}}</a:t>
             </a:r>
           </a:p>
         </p:txBody>
@@ -7190,7 +7190,7 @@
                 </a:solidFill>
                 <a:latin typeface="Calibri"/>
               </a:rPr>
-              <a:t>02</a:t>
+              <a:t>{{NUM_2}}</a:t>
             </a:r>
           </a:p>
         </p:txBody>
@@ -7260,7 +7260,7 @@
                 </a:solidFill>
                 <a:latin typeface="Calibri"/>
               </a:rPr>
-              <a:t>03</a:t>
+              <a:t>{{NUM_3}}</a:t>
             </a:r>
           </a:p>
         </p:txBody>
@@ -7330,7 +7330,7 @@
                 </a:solidFill>
                 <a:latin typeface="Calibri"/>
               </a:rPr>
-              <a:t>04</a:t>
+              <a:t>{{NUM_4}}</a:t>
             </a:r>
           </a:p>
         </p:txBody>
@@ -7400,7 +7400,7 @@
                 </a:solidFill>
                 <a:latin typeface="Calibri"/>
               </a:rPr>
-              <a:t>05</a:t>
+              <a:t>{{NUM_5}}</a:t>
             </a:r>
           </a:p>
         </p:txBody>
@@ -7470,7 +7470,7 @@
                 </a:solidFill>
                 <a:latin typeface="Calibri"/>
               </a:rPr>
-              <a:t>06</a:t>
+              <a:t>{{NUM_6}}</a:t>
             </a:r>
           </a:p>
         </p:txBody>
@@ -7540,7 +7540,7 @@
                 </a:solidFill>
                 <a:latin typeface="Calibri"/>
               </a:rPr>
-              <a:t>07</a:t>
+              <a:t>{{NUM_7}}</a:t>
             </a:r>
           </a:p>
         </p:txBody>
@@ -7610,7 +7610,7 @@
                 </a:solidFill>
                 <a:latin typeface="Calibri"/>
               </a:rPr>
-              <a:t>08</a:t>
+              <a:t>{{NUM_8}}</a:t>
             </a:r>
           </a:p>
         </p:txBody>
@@ -7680,7 +7680,7 @@
                 </a:solidFill>
                 <a:latin typeface="Calibri"/>
               </a:rPr>
-              <a:t>09</a:t>
+              <a:t>{{NUM_9}}</a:t>
             </a:r>
           </a:p>
         </p:txBody>
@@ -7750,7 +7750,7 @@
                 </a:solidFill>
                 <a:latin typeface="Calibri"/>
               </a:rPr>
-              <a:t>10</a:t>
+              <a:t>{{NUM_10}}</a:t>
             </a:r>
           </a:p>
         </p:txBody>

</xml_diff>